<commit_message>
Ligero cambio en una presentacion, para asegurar el comando push ahora solo sera git push, pues antes era git push --set-upstream origin main
</commit_message>
<xml_diff>
--- a/tareas/04-control-versiones/Control-de-versiones.pptx
+++ b/tareas/04-control-versiones/Control-de-versiones.pptx
@@ -4848,7 +4848,29 @@
                 <a:ea typeface="Calibri" pitchFamily="34" charset="-122"/>
                 <a:cs typeface="Calibri" pitchFamily="34" charset="-120"/>
               </a:rPr>
-              <a:t>El docente puede clonarlo, compilarlo y revisar el historial completo desde un enlace público.</a:t>
+              <a:t>El docente puede clonarlo, compilarlo y revisar el historial completo desde un enlace </a:t>
+            </a:r>
+            <a:r>
+              <a:rPr lang="en-US" sz="1250" dirty="0" err="1">
+                <a:solidFill>
+                  <a:srgbClr val="C1D0E2"/>
+                </a:solidFill>
+                <a:latin typeface="Calibri" pitchFamily="34" charset="0"/>
+                <a:ea typeface="Calibri" pitchFamily="34" charset="-122"/>
+                <a:cs typeface="Calibri" pitchFamily="34" charset="-120"/>
+              </a:rPr>
+              <a:t>público</a:t>
+            </a:r>
+            <a:r>
+              <a:rPr lang="en-US" sz="1250">
+                <a:solidFill>
+                  <a:srgbClr val="C1D0E2"/>
+                </a:solidFill>
+                <a:latin typeface="Calibri" pitchFamily="34" charset="0"/>
+                <a:ea typeface="Calibri" pitchFamily="34" charset="-122"/>
+                <a:cs typeface="Calibri" pitchFamily="34" charset="-120"/>
+              </a:rPr>
+              <a:t> .</a:t>
             </a:r>
             <a:endParaRPr lang="en-US" sz="1250" dirty="0"/>
           </a:p>

</xml_diff>